<commit_message>
feat: update 발표자료 초안
</commit_message>
<xml_diff>
--- a/presentation/2강3강_발표자료_초안.pptx
+++ b/presentation/2강3강_발표자료_초안.pptx
@@ -4245,16 +4245,16 @@
         </p:nvSpPr>
         <p:spPr>
           <a:xfrm>
-            <a:off x="4206240" y="2404872"/>
-            <a:ext cx="2377440" cy="274320"/>
-          </a:xfrm>
-          <a:prstGeom prst="rect">
-            <a:avLst/>
-          </a:prstGeom>
-          <a:noFill/>
-        </p:spPr>
-        <p:txBody>
-          <a:bodyPr wrap="square" anchor="t" lIns="0" rIns="0" tIns="0" bIns="0">
+            <a:off x="3886200" y="2404872"/>
+            <a:ext cx="3017520" cy="274320"/>
+          </a:xfrm>
+          <a:prstGeom prst="rect">
+            <a:avLst/>
+          </a:prstGeom>
+          <a:noFill/>
+        </p:spPr>
+        <p:txBody>
+          <a:bodyPr wrap="none" anchor="t" lIns="0" rIns="0" tIns="0" bIns="0">
             <a:spAutoFit/>
           </a:bodyPr>
           <a:lstStyle/>
@@ -4339,16 +4339,16 @@
         </p:nvSpPr>
         <p:spPr>
           <a:xfrm>
-            <a:off x="6583679" y="2404872"/>
-            <a:ext cx="566928" cy="274320"/>
-          </a:xfrm>
-          <a:prstGeom prst="rect">
-            <a:avLst/>
-          </a:prstGeom>
-          <a:noFill/>
-        </p:spPr>
-        <p:txBody>
-          <a:bodyPr wrap="square" anchor="t" lIns="0" rIns="0" tIns="0" bIns="0">
+            <a:off x="6263640" y="2404872"/>
+            <a:ext cx="1207007" cy="274320"/>
+          </a:xfrm>
+          <a:prstGeom prst="rect">
+            <a:avLst/>
+          </a:prstGeom>
+          <a:noFill/>
+        </p:spPr>
+        <p:txBody>
+          <a:bodyPr wrap="none" anchor="t" lIns="0" rIns="0" tIns="0" bIns="0">
             <a:spAutoFit/>
           </a:bodyPr>
           <a:lstStyle/>
@@ -4825,16 +4825,16 @@
         </p:nvSpPr>
         <p:spPr>
           <a:xfrm>
-            <a:off x="3327044" y="2244851"/>
-            <a:ext cx="1247241" cy="274320"/>
-          </a:xfrm>
-          <a:prstGeom prst="rect">
-            <a:avLst/>
-          </a:prstGeom>
-          <a:noFill/>
-        </p:spPr>
-        <p:txBody>
-          <a:bodyPr wrap="square" anchor="t" lIns="0" rIns="0" tIns="0" bIns="0">
+            <a:off x="3007004" y="2244851"/>
+            <a:ext cx="1887321" cy="274320"/>
+          </a:xfrm>
+          <a:prstGeom prst="rect">
+            <a:avLst/>
+          </a:prstGeom>
+          <a:noFill/>
+        </p:spPr>
+        <p:txBody>
+          <a:bodyPr wrap="none" anchor="t" lIns="0" rIns="0" tIns="0" bIns="0">
             <a:spAutoFit/>
           </a:bodyPr>
           <a:lstStyle/>
@@ -4958,16 +4958,16 @@
         </p:nvSpPr>
         <p:spPr>
           <a:xfrm>
-            <a:off x="5479542" y="2244851"/>
-            <a:ext cx="453542" cy="274320"/>
-          </a:xfrm>
-          <a:prstGeom prst="rect">
-            <a:avLst/>
-          </a:prstGeom>
-          <a:noFill/>
-        </p:spPr>
-        <p:txBody>
-          <a:bodyPr wrap="square" anchor="t" lIns="0" rIns="0" tIns="0" bIns="0">
+            <a:off x="5159502" y="2244851"/>
+            <a:ext cx="1093622" cy="274320"/>
+          </a:xfrm>
+          <a:prstGeom prst="rect">
+            <a:avLst/>
+          </a:prstGeom>
+          <a:noFill/>
+        </p:spPr>
+        <p:txBody>
+          <a:bodyPr wrap="none" anchor="t" lIns="0" rIns="0" tIns="0" bIns="0">
             <a:spAutoFit/>
           </a:bodyPr>
           <a:lstStyle/>
@@ -5091,16 +5091,16 @@
         </p:nvSpPr>
         <p:spPr>
           <a:xfrm>
-            <a:off x="6838340" y="2244851"/>
-            <a:ext cx="453542" cy="274320"/>
-          </a:xfrm>
-          <a:prstGeom prst="rect">
-            <a:avLst/>
-          </a:prstGeom>
-          <a:noFill/>
-        </p:spPr>
-        <p:txBody>
-          <a:bodyPr wrap="square" anchor="t" lIns="0" rIns="0" tIns="0" bIns="0">
+            <a:off x="6518300" y="2244851"/>
+            <a:ext cx="1093622" cy="274320"/>
+          </a:xfrm>
+          <a:prstGeom prst="rect">
+            <a:avLst/>
+          </a:prstGeom>
+          <a:noFill/>
+        </p:spPr>
+        <p:txBody>
+          <a:bodyPr wrap="none" anchor="t" lIns="0" rIns="0" tIns="0" bIns="0">
             <a:spAutoFit/>
           </a:bodyPr>
           <a:lstStyle/>
@@ -6508,16 +6508,16 @@
         </p:nvSpPr>
         <p:spPr>
           <a:xfrm>
-            <a:off x="2732684" y="2884932"/>
-            <a:ext cx="1077163" cy="274320"/>
-          </a:xfrm>
-          <a:prstGeom prst="rect">
-            <a:avLst/>
-          </a:prstGeom>
-          <a:noFill/>
-        </p:spPr>
-        <p:txBody>
-          <a:bodyPr wrap="square" anchor="t" lIns="0" rIns="0" tIns="0" bIns="0">
+            <a:off x="2412644" y="2884932"/>
+            <a:ext cx="1717243" cy="274320"/>
+          </a:xfrm>
+          <a:prstGeom prst="rect">
+            <a:avLst/>
+          </a:prstGeom>
+          <a:noFill/>
+        </p:spPr>
+        <p:txBody>
+          <a:bodyPr wrap="none" anchor="t" lIns="0" rIns="0" tIns="0" bIns="0">
             <a:spAutoFit/>
           </a:bodyPr>
           <a:lstStyle/>
@@ -6641,16 +6641,16 @@
         </p:nvSpPr>
         <p:spPr>
           <a:xfrm>
-            <a:off x="4715103" y="2884932"/>
-            <a:ext cx="453542" cy="274320"/>
-          </a:xfrm>
-          <a:prstGeom prst="rect">
-            <a:avLst/>
-          </a:prstGeom>
-          <a:noFill/>
-        </p:spPr>
-        <p:txBody>
-          <a:bodyPr wrap="square" anchor="t" lIns="0" rIns="0" tIns="0" bIns="0">
+            <a:off x="4395063" y="2884932"/>
+            <a:ext cx="1093622" cy="274320"/>
+          </a:xfrm>
+          <a:prstGeom prst="rect">
+            <a:avLst/>
+          </a:prstGeom>
+          <a:noFill/>
+        </p:spPr>
+        <p:txBody>
+          <a:bodyPr wrap="none" anchor="t" lIns="0" rIns="0" tIns="0" bIns="0">
             <a:spAutoFit/>
           </a:bodyPr>
           <a:lstStyle/>
@@ -6774,16 +6774,16 @@
         </p:nvSpPr>
         <p:spPr>
           <a:xfrm>
-            <a:off x="6073902" y="2884932"/>
-            <a:ext cx="453542" cy="274320"/>
-          </a:xfrm>
-          <a:prstGeom prst="rect">
-            <a:avLst/>
-          </a:prstGeom>
-          <a:noFill/>
-        </p:spPr>
-        <p:txBody>
-          <a:bodyPr wrap="square" anchor="t" lIns="0" rIns="0" tIns="0" bIns="0">
+            <a:off x="5753862" y="2884932"/>
+            <a:ext cx="1093622" cy="274320"/>
+          </a:xfrm>
+          <a:prstGeom prst="rect">
+            <a:avLst/>
+          </a:prstGeom>
+          <a:noFill/>
+        </p:spPr>
+        <p:txBody>
+          <a:bodyPr wrap="none" anchor="t" lIns="0" rIns="0" tIns="0" bIns="0">
             <a:spAutoFit/>
           </a:bodyPr>
           <a:lstStyle/>
@@ -6907,16 +6907,16 @@
         </p:nvSpPr>
         <p:spPr>
           <a:xfrm>
-            <a:off x="7432700" y="2884932"/>
-            <a:ext cx="453542" cy="274320"/>
-          </a:xfrm>
-          <a:prstGeom prst="rect">
-            <a:avLst/>
-          </a:prstGeom>
-          <a:noFill/>
-        </p:spPr>
-        <p:txBody>
-          <a:bodyPr wrap="square" anchor="t" lIns="0" rIns="0" tIns="0" bIns="0">
+            <a:off x="7112660" y="2884932"/>
+            <a:ext cx="1093622" cy="274320"/>
+          </a:xfrm>
+          <a:prstGeom prst="rect">
+            <a:avLst/>
+          </a:prstGeom>
+          <a:noFill/>
+        </p:spPr>
+        <p:txBody>
+          <a:bodyPr wrap="none" anchor="t" lIns="0" rIns="0" tIns="0" bIns="0">
             <a:spAutoFit/>
           </a:bodyPr>
           <a:lstStyle/>
@@ -6977,15 +6977,211 @@
           </a:p>
         </p:txBody>
       </p:sp>
-      <p:sp>
-        <p:nvSpPr>
-          <p:cNvPr id="18" name="TextBox 17"/>
-          <p:cNvSpPr txBox="1"/>
-          <p:nvPr/>
-        </p:nvSpPr>
-        <p:spPr>
-          <a:xfrm>
-            <a:off x="685800" y="3977639"/>
+      <p:cxnSp>
+        <p:nvCxnSpPr>
+          <p:cNvPr id="18" name="Connector 17"/>
+          <p:cNvCxnSpPr/>
+          <p:nvPr/>
+        </p:nvCxnSpPr>
+        <p:spPr>
+          <a:xfrm>
+            <a:off x="3108960" y="3406140"/>
+            <a:ext cx="5943600" cy="0"/>
+          </a:xfrm>
+          <a:prstGeom prst="line">
+            <a:avLst/>
+          </a:prstGeom>
+          <a:ln w="19050">
+            <a:solidFill>
+              <a:srgbClr val="C7CBD3"/>
+            </a:solidFill>
+          </a:ln>
+        </p:spPr>
+        <p:style>
+          <a:lnRef idx="2">
+            <a:schemeClr val="accent1"/>
+          </a:lnRef>
+          <a:fillRef idx="0">
+            <a:schemeClr val="accent1"/>
+          </a:fillRef>
+          <a:effectRef idx="1">
+            <a:schemeClr val="accent1"/>
+          </a:effectRef>
+          <a:fontRef idx="minor">
+            <a:schemeClr val="tx1"/>
+          </a:fontRef>
+        </p:style>
+      </p:cxnSp>
+      <p:sp>
+        <p:nvSpPr>
+          <p:cNvPr id="19" name="Rectangle 18"/>
+          <p:cNvSpPr/>
+          <p:nvPr/>
+        </p:nvSpPr>
+        <p:spPr>
+          <a:xfrm>
+            <a:off x="5605272" y="3323844"/>
+            <a:ext cx="950976" cy="164592"/>
+          </a:xfrm>
+          <a:prstGeom prst="rect">
+            <a:avLst/>
+          </a:prstGeom>
+          <a:solidFill>
+            <a:srgbClr val="B3361E"/>
+          </a:solidFill>
+          <a:ln>
+            <a:noFill/>
+          </a:ln>
+          <a:effectLst/>
+        </p:spPr>
+        <p:style>
+          <a:lnRef idx="1">
+            <a:schemeClr val="accent1"/>
+          </a:lnRef>
+          <a:fillRef idx="3">
+            <a:schemeClr val="accent1"/>
+          </a:fillRef>
+          <a:effectRef idx="2">
+            <a:schemeClr val="accent1"/>
+          </a:effectRef>
+          <a:fontRef idx="minor">
+            <a:schemeClr val="lt1"/>
+          </a:fontRef>
+        </p:style>
+        <p:txBody>
+          <a:bodyPr rtlCol="0" anchor="ctr"/>
+          <a:lstStyle/>
+          <a:p>
+            <a:pPr algn="ctr"/>
+          </a:p>
+        </p:txBody>
+      </p:sp>
+      <p:sp>
+        <p:nvSpPr>
+          <p:cNvPr id="20" name="TextBox 19"/>
+          <p:cNvSpPr txBox="1"/>
+          <p:nvPr/>
+        </p:nvSpPr>
+        <p:spPr>
+          <a:xfrm>
+            <a:off x="5605272" y="3543300"/>
+            <a:ext cx="950976" cy="320040"/>
+          </a:xfrm>
+          <a:prstGeom prst="rect">
+            <a:avLst/>
+          </a:prstGeom>
+          <a:noFill/>
+        </p:spPr>
+        <p:txBody>
+          <a:bodyPr wrap="square" anchor="t" lIns="0" rIns="0" tIns="0" bIns="0">
+            <a:spAutoFit/>
+          </a:bodyPr>
+          <a:lstStyle/>
+          <a:p>
+            <a:pPr algn="ctr">
+              <a:lnSpc>
+                <a:spcPct val="115000"/>
+              </a:lnSpc>
+            </a:pPr>
+            <a:r>
+              <a:rPr sz="1300" b="0" i="0">
+                <a:solidFill>
+                  <a:srgbClr val="5A5A5A"/>
+                </a:solidFill>
+                <a:latin typeface="맑은 고딕"/>
+              </a:rPr>
+              <a:t>eᵢ ∈ [-B,B]</a:t>
+            </a:r>
+          </a:p>
+        </p:txBody>
+      </p:sp>
+      <p:sp>
+        <p:nvSpPr>
+          <p:cNvPr id="21" name="TextBox 20"/>
+          <p:cNvSpPr txBox="1"/>
+          <p:nvPr/>
+        </p:nvSpPr>
+        <p:spPr>
+          <a:xfrm>
+            <a:off x="2971800" y="3154680"/>
+            <a:ext cx="822960" cy="274320"/>
+          </a:xfrm>
+          <a:prstGeom prst="rect">
+            <a:avLst/>
+          </a:prstGeom>
+          <a:noFill/>
+        </p:spPr>
+        <p:txBody>
+          <a:bodyPr wrap="square" anchor="t" lIns="0" rIns="0" tIns="0" bIns="0">
+            <a:spAutoFit/>
+          </a:bodyPr>
+          <a:lstStyle/>
+          <a:p>
+            <a:pPr algn="l">
+              <a:lnSpc>
+                <a:spcPct val="115000"/>
+              </a:lnSpc>
+            </a:pPr>
+            <a:r>
+              <a:rPr sz="1400" b="0" i="1">
+                <a:solidFill>
+                  <a:srgbClr val="222222"/>
+                </a:solidFill>
+                <a:latin typeface="맑은 고딕"/>
+              </a:rPr>
+              <a:t>-q</a:t>
+            </a:r>
+          </a:p>
+        </p:txBody>
+      </p:sp>
+      <p:sp>
+        <p:nvSpPr>
+          <p:cNvPr id="22" name="TextBox 21"/>
+          <p:cNvSpPr txBox="1"/>
+          <p:nvPr/>
+        </p:nvSpPr>
+        <p:spPr>
+          <a:xfrm>
+            <a:off x="8366760" y="3154680"/>
+            <a:ext cx="822960" cy="274320"/>
+          </a:xfrm>
+          <a:prstGeom prst="rect">
+            <a:avLst/>
+          </a:prstGeom>
+          <a:noFill/>
+        </p:spPr>
+        <p:txBody>
+          <a:bodyPr wrap="square" anchor="t" lIns="0" rIns="0" tIns="0" bIns="0">
+            <a:spAutoFit/>
+          </a:bodyPr>
+          <a:lstStyle/>
+          <a:p>
+            <a:pPr algn="r">
+              <a:lnSpc>
+                <a:spcPct val="115000"/>
+              </a:lnSpc>
+            </a:pPr>
+            <a:r>
+              <a:rPr sz="1400" b="0" i="1">
+                <a:solidFill>
+                  <a:srgbClr val="222222"/>
+                </a:solidFill>
+                <a:latin typeface="맑은 고딕"/>
+              </a:rPr>
+              <a:t>q</a:t>
+            </a:r>
+          </a:p>
+        </p:txBody>
+      </p:sp>
+      <p:sp>
+        <p:nvSpPr>
+          <p:cNvPr id="23" name="TextBox 22"/>
+          <p:cNvSpPr txBox="1"/>
+          <p:nvPr/>
+        </p:nvSpPr>
+        <p:spPr>
+          <a:xfrm>
+            <a:off x="685800" y="4023360"/>
             <a:ext cx="10789920" cy="1005840"/>
           </a:xfrm>
           <a:prstGeom prst="rect">
@@ -7021,15 +7217,15 @@
       </p:sp>
       <p:graphicFrame>
         <p:nvGraphicFramePr>
-          <p:cNvPr id="19" name="Table 18"/>
+          <p:cNvPr id="24" name="Table 23"/>
           <p:cNvGraphicFramePr>
             <a:graphicFrameLocks noGrp="1"/>
           </p:cNvGraphicFramePr>
           <p:nvPr/>
         </p:nvGraphicFramePr>
         <p:xfrm>
-          <a:off x="1280160" y="5074920"/>
-          <a:ext cx="9601198" cy="1417320"/>
+          <a:off x="1280160" y="5120640"/>
+          <a:ext cx="9601198" cy="1371600"/>
         </p:xfrm>
         <a:graphic>
           <a:graphicData uri="http://schemas.openxmlformats.org/drawingml/2006/table">
@@ -7042,7 +7238,7 @@
                 <a:gridCol w="3749039"/>
                 <a:gridCol w="3749039"/>
               </a:tblGrid>
-              <a:tr h="472440">
+              <a:tr h="457200">
                 <a:tc>
                   <a:txBody>
                     <a:bodyPr/>
@@ -7104,7 +7300,7 @@
                   </a:tcPr>
                 </a:tc>
               </a:tr>
-              <a:tr h="472440">
+              <a:tr h="457200">
                 <a:tc>
                   <a:txBody>
                     <a:bodyPr/>
@@ -7175,7 +7371,7 @@
                   </a:tcPr>
                 </a:tc>
               </a:tr>
-              <a:tr h="472440">
+              <a:tr h="457200">
                 <a:tc>
                   <a:txBody>
                     <a:bodyPr/>
@@ -7439,14 +7635,241 @@
       </p:sp>
       <p:sp>
         <p:nvSpPr>
-          <p:cNvPr id="6" name="TextBox 5"/>
-          <p:cNvSpPr txBox="1"/>
-          <p:nvPr/>
-        </p:nvSpPr>
-        <p:spPr>
-          <a:xfrm>
-            <a:off x="685800" y="1554480"/>
-            <a:ext cx="10789920" cy="4206240"/>
+          <p:cNvPr id="6" name="Rectangle 5"/>
+          <p:cNvSpPr/>
+          <p:nvPr/>
+        </p:nvSpPr>
+        <p:spPr>
+          <a:xfrm>
+            <a:off x="1280160" y="1645920"/>
+            <a:ext cx="4297680" cy="1188720"/>
+          </a:xfrm>
+          <a:prstGeom prst="rect">
+            <a:avLst/>
+          </a:prstGeom>
+          <a:solidFill>
+            <a:srgbClr val="F4F5F7"/>
+          </a:solidFill>
+          <a:ln w="15875">
+            <a:solidFill>
+              <a:srgbClr val="C7CBD3"/>
+            </a:solidFill>
+          </a:ln>
+          <a:effectLst/>
+        </p:spPr>
+        <p:style>
+          <a:lnRef idx="1">
+            <a:schemeClr val="accent1"/>
+          </a:lnRef>
+          <a:fillRef idx="3">
+            <a:schemeClr val="accent1"/>
+          </a:fillRef>
+          <a:effectRef idx="2">
+            <a:schemeClr val="accent1"/>
+          </a:effectRef>
+          <a:fontRef idx="minor">
+            <a:schemeClr val="lt1"/>
+          </a:fontRef>
+        </p:style>
+        <p:txBody>
+          <a:bodyPr rtlCol="0" anchor="ctr" wrap="square"/>
+          <a:lstStyle/>
+          <a:p>
+            <a:pPr algn="ctr"/>
+            <a:r>
+              <a:rPr sz="2200" b="0" i="0">
+                <a:solidFill>
+                  <a:srgbClr val="222222"/>
+                </a:solidFill>
+                <a:latin typeface="Cambria Math"/>
+              </a:rPr>
+              <a:t>As ≡ b (mod q)</a:t>
+            </a:r>
+          </a:p>
+        </p:txBody>
+      </p:sp>
+      <p:sp>
+        <p:nvSpPr>
+          <p:cNvPr id="7" name="Rectangle 6"/>
+          <p:cNvSpPr/>
+          <p:nvPr/>
+        </p:nvSpPr>
+        <p:spPr>
+          <a:xfrm>
+            <a:off x="6583680" y="1645920"/>
+            <a:ext cx="4297680" cy="1188720"/>
+          </a:xfrm>
+          <a:prstGeom prst="rect">
+            <a:avLst/>
+          </a:prstGeom>
+          <a:solidFill>
+            <a:srgbClr val="E3F1EF"/>
+          </a:solidFill>
+          <a:ln w="15875">
+            <a:solidFill>
+              <a:srgbClr val="C7CBD3"/>
+            </a:solidFill>
+          </a:ln>
+          <a:effectLst/>
+        </p:spPr>
+        <p:style>
+          <a:lnRef idx="1">
+            <a:schemeClr val="accent1"/>
+          </a:lnRef>
+          <a:fillRef idx="3">
+            <a:schemeClr val="accent1"/>
+          </a:fillRef>
+          <a:effectRef idx="2">
+            <a:schemeClr val="accent1"/>
+          </a:effectRef>
+          <a:fontRef idx="minor">
+            <a:schemeClr val="lt1"/>
+          </a:fontRef>
+        </p:style>
+        <p:txBody>
+          <a:bodyPr rtlCol="0" anchor="ctr" wrap="square"/>
+          <a:lstStyle/>
+          <a:p>
+            <a:pPr algn="ctr"/>
+            <a:r>
+              <a:rPr sz="2200" b="0" i="0">
+                <a:solidFill>
+                  <a:srgbClr val="222222"/>
+                </a:solidFill>
+                <a:latin typeface="Cambria Math"/>
+              </a:rPr>
+              <a:t>As + e ≡ b (mod q)</a:t>
+            </a:r>
+          </a:p>
+        </p:txBody>
+      </p:sp>
+      <p:sp>
+        <p:nvSpPr>
+          <p:cNvPr id="8" name="TextBox 7"/>
+          <p:cNvSpPr txBox="1"/>
+          <p:nvPr/>
+        </p:nvSpPr>
+        <p:spPr>
+          <a:xfrm>
+            <a:off x="5532120" y="2011680"/>
+            <a:ext cx="914400" cy="548640"/>
+          </a:xfrm>
+          <a:prstGeom prst="rect">
+            <a:avLst/>
+          </a:prstGeom>
+          <a:noFill/>
+        </p:spPr>
+        <p:txBody>
+          <a:bodyPr wrap="square" anchor="ctr" lIns="0" rIns="0" tIns="0" bIns="0">
+            <a:spAutoFit/>
+          </a:bodyPr>
+          <a:lstStyle/>
+          <a:p>
+            <a:pPr algn="ctr">
+              <a:lnSpc>
+                <a:spcPct val="115000"/>
+              </a:lnSpc>
+            </a:pPr>
+            <a:r>
+              <a:rPr sz="3000" b="0" i="0">
+                <a:solidFill>
+                  <a:srgbClr val="222222"/>
+                </a:solidFill>
+                <a:latin typeface="맑은 고딕"/>
+              </a:rPr>
+              <a:t>→</a:t>
+            </a:r>
+          </a:p>
+        </p:txBody>
+      </p:sp>
+      <p:sp>
+        <p:nvSpPr>
+          <p:cNvPr id="9" name="TextBox 8"/>
+          <p:cNvSpPr txBox="1"/>
+          <p:nvPr/>
+        </p:nvSpPr>
+        <p:spPr>
+          <a:xfrm>
+            <a:off x="1280160" y="2880360"/>
+            <a:ext cx="4297680" cy="411480"/>
+          </a:xfrm>
+          <a:prstGeom prst="rect">
+            <a:avLst/>
+          </a:prstGeom>
+          <a:noFill/>
+        </p:spPr>
+        <p:txBody>
+          <a:bodyPr wrap="square" anchor="t" lIns="0" rIns="0" tIns="0" bIns="0">
+            <a:spAutoFit/>
+          </a:bodyPr>
+          <a:lstStyle/>
+          <a:p>
+            <a:pPr algn="ctr">
+              <a:lnSpc>
+                <a:spcPct val="115000"/>
+              </a:lnSpc>
+            </a:pPr>
+            <a:r>
+              <a:rPr sz="1350" b="0" i="0">
+                <a:solidFill>
+                  <a:srgbClr val="5A5A5A"/>
+                </a:solidFill>
+                <a:latin typeface="맑은 고딕"/>
+              </a:rPr>
+              <a:t>e = 0 — 정확한 선형방정식</a:t>
+            </a:r>
+          </a:p>
+        </p:txBody>
+      </p:sp>
+      <p:sp>
+        <p:nvSpPr>
+          <p:cNvPr id="10" name="TextBox 9"/>
+          <p:cNvSpPr txBox="1"/>
+          <p:nvPr/>
+        </p:nvSpPr>
+        <p:spPr>
+          <a:xfrm>
+            <a:off x="6583680" y="2880360"/>
+            <a:ext cx="4297680" cy="411480"/>
+          </a:xfrm>
+          <a:prstGeom prst="rect">
+            <a:avLst/>
+          </a:prstGeom>
+          <a:noFill/>
+        </p:spPr>
+        <p:txBody>
+          <a:bodyPr wrap="square" anchor="t" lIns="0" rIns="0" tIns="0" bIns="0">
+            <a:spAutoFit/>
+          </a:bodyPr>
+          <a:lstStyle/>
+          <a:p>
+            <a:pPr algn="ctr">
+              <a:lnSpc>
+                <a:spcPct val="115000"/>
+              </a:lnSpc>
+            </a:pPr>
+            <a:r>
+              <a:rPr sz="1350" b="0" i="0">
+                <a:solidFill>
+                  <a:srgbClr val="5A5A5A"/>
+                </a:solidFill>
+                <a:latin typeface="맑은 고딕"/>
+              </a:rPr>
+              <a:t>e ≠ 0 — 잡음 섞인 방정식</a:t>
+            </a:r>
+          </a:p>
+        </p:txBody>
+      </p:sp>
+      <p:sp>
+        <p:nvSpPr>
+          <p:cNvPr id="11" name="TextBox 10"/>
+          <p:cNvSpPr txBox="1"/>
+          <p:nvPr/>
+        </p:nvSpPr>
+        <p:spPr>
+          <a:xfrm>
+            <a:off x="685800" y="3383280"/>
+            <a:ext cx="10789920" cy="2743200"/>
           </a:xfrm>
           <a:prstGeom prst="rect">
             <a:avLst/>
@@ -7464,11 +7887,11 @@
                 <a:spcPct val="125000"/>
               </a:lnSpc>
               <a:spcAft>
-                <a:spcPts val="1800"/>
+                <a:spcPts val="1600"/>
               </a:spcAft>
             </a:pPr>
             <a:r>
-              <a:rPr sz="2000">
+              <a:rPr sz="1900">
                 <a:solidFill>
                   <a:srgbClr val="222222"/>
                 </a:solidFill>
@@ -7483,11 +7906,11 @@
                 <a:spcPct val="125000"/>
               </a:lnSpc>
               <a:spcAft>
-                <a:spcPts val="1800"/>
+                <a:spcPts val="1600"/>
               </a:spcAft>
             </a:pPr>
             <a:r>
-              <a:rPr sz="2000">
+              <a:rPr sz="1900">
                 <a:solidFill>
                   <a:srgbClr val="222222"/>
                 </a:solidFill>
@@ -7502,11 +7925,11 @@
                 <a:spcPct val="125000"/>
               </a:lnSpc>
               <a:spcAft>
-                <a:spcPts val="1800"/>
+                <a:spcPts val="1600"/>
               </a:spcAft>
             </a:pPr>
             <a:r>
-              <a:rPr sz="2000">
+              <a:rPr sz="1900">
                 <a:solidFill>
                   <a:srgbClr val="222222"/>
                 </a:solidFill>
@@ -9579,14 +10002,619 @@
       </p:sp>
       <p:sp>
         <p:nvSpPr>
-          <p:cNvPr id="6" name="TextBox 5"/>
-          <p:cNvSpPr txBox="1"/>
-          <p:nvPr/>
-        </p:nvSpPr>
-        <p:spPr>
-          <a:xfrm>
-            <a:off x="685800" y="1463040"/>
-            <a:ext cx="10789920" cy="4572000"/>
+          <p:cNvPr id="6" name="Rounded Rectangle 5"/>
+          <p:cNvSpPr/>
+          <p:nvPr/>
+        </p:nvSpPr>
+        <p:spPr>
+          <a:xfrm>
+            <a:off x="914400" y="1417320"/>
+            <a:ext cx="10332720" cy="1874519"/>
+          </a:xfrm>
+          <a:prstGeom prst="roundRect">
+            <a:avLst/>
+          </a:prstGeom>
+          <a:solidFill>
+            <a:srgbClr val="F4F5F7"/>
+          </a:solidFill>
+          <a:ln>
+            <a:solidFill>
+              <a:srgbClr val="C7CBD3"/>
+            </a:solidFill>
+          </a:ln>
+          <a:effectLst/>
+        </p:spPr>
+        <p:style>
+          <a:lnRef idx="1">
+            <a:schemeClr val="accent1"/>
+          </a:lnRef>
+          <a:fillRef idx="3">
+            <a:schemeClr val="accent1"/>
+          </a:fillRef>
+          <a:effectRef idx="2">
+            <a:schemeClr val="accent1"/>
+          </a:effectRef>
+          <a:fontRef idx="minor">
+            <a:schemeClr val="lt1"/>
+          </a:fontRef>
+        </p:style>
+        <p:txBody>
+          <a:bodyPr rtlCol="0" anchor="ctr"/>
+          <a:lstStyle/>
+          <a:p>
+            <a:pPr algn="ctr"/>
+          </a:p>
+        </p:txBody>
+      </p:sp>
+      <p:sp>
+        <p:nvSpPr>
+          <p:cNvPr id="7" name="Oval 6"/>
+          <p:cNvSpPr/>
+          <p:nvPr/>
+        </p:nvSpPr>
+        <p:spPr>
+          <a:xfrm>
+            <a:off x="1097280" y="1714500"/>
+            <a:ext cx="768096" cy="768096"/>
+          </a:xfrm>
+          <a:prstGeom prst="ellipse">
+            <a:avLst/>
+          </a:prstGeom>
+          <a:noFill/>
+          <a:ln w="22225">
+            <a:solidFill>
+              <a:srgbClr val="B8860B"/>
+            </a:solidFill>
+            <a:prstDash val="dash"/>
+          </a:ln>
+          <a:effectLst/>
+        </p:spPr>
+        <p:style>
+          <a:lnRef idx="1">
+            <a:schemeClr val="accent1"/>
+          </a:lnRef>
+          <a:fillRef idx="3">
+            <a:schemeClr val="accent1"/>
+          </a:fillRef>
+          <a:effectRef idx="2">
+            <a:schemeClr val="accent1"/>
+          </a:effectRef>
+          <a:fontRef idx="minor">
+            <a:schemeClr val="lt1"/>
+          </a:fontRef>
+        </p:style>
+        <p:txBody>
+          <a:bodyPr rtlCol="0" anchor="ctr"/>
+          <a:lstStyle/>
+          <a:p>
+            <a:pPr algn="ctr"/>
+          </a:p>
+        </p:txBody>
+      </p:sp>
+      <p:sp>
+        <p:nvSpPr>
+          <p:cNvPr id="8" name="Oval 7"/>
+          <p:cNvSpPr/>
+          <p:nvPr/>
+        </p:nvSpPr>
+        <p:spPr>
+          <a:xfrm>
+            <a:off x="1440180" y="2057400"/>
+            <a:ext cx="82296" cy="82296"/>
+          </a:xfrm>
+          <a:prstGeom prst="ellipse">
+            <a:avLst/>
+          </a:prstGeom>
+          <a:solidFill>
+            <a:srgbClr val="B3361E"/>
+          </a:solidFill>
+          <a:ln>
+            <a:solidFill>
+              <a:srgbClr val="B3361E"/>
+            </a:solidFill>
+          </a:ln>
+          <a:effectLst/>
+        </p:spPr>
+        <p:style>
+          <a:lnRef idx="1">
+            <a:schemeClr val="accent1"/>
+          </a:lnRef>
+          <a:fillRef idx="3">
+            <a:schemeClr val="accent1"/>
+          </a:fillRef>
+          <a:effectRef idx="2">
+            <a:schemeClr val="accent1"/>
+          </a:effectRef>
+          <a:fontRef idx="minor">
+            <a:schemeClr val="lt1"/>
+          </a:fontRef>
+        </p:style>
+        <p:txBody>
+          <a:bodyPr rtlCol="0" anchor="ctr"/>
+          <a:lstStyle/>
+          <a:p>
+            <a:pPr algn="ctr"/>
+          </a:p>
+        </p:txBody>
+      </p:sp>
+      <p:sp>
+        <p:nvSpPr>
+          <p:cNvPr id="9" name="TextBox 8"/>
+          <p:cNvSpPr txBox="1"/>
+          <p:nvPr/>
+        </p:nvSpPr>
+        <p:spPr>
+          <a:xfrm>
+            <a:off x="978407" y="1403604"/>
+            <a:ext cx="1005840" cy="274320"/>
+          </a:xfrm>
+          <a:prstGeom prst="rect">
+            <a:avLst/>
+          </a:prstGeom>
+          <a:noFill/>
+        </p:spPr>
+        <p:txBody>
+          <a:bodyPr wrap="square" anchor="t" lIns="0" rIns="0" tIns="0" bIns="0">
+            <a:spAutoFit/>
+          </a:bodyPr>
+          <a:lstStyle/>
+          <a:p>
+            <a:pPr algn="ctr">
+              <a:lnSpc>
+                <a:spcPct val="115000"/>
+              </a:lnSpc>
+            </a:pPr>
+            <a:r>
+              <a:rPr sz="1300" b="0" i="1">
+                <a:solidFill>
+                  <a:srgbClr val="222222"/>
+                </a:solidFill>
+                <a:latin typeface="맑은 고딕"/>
+              </a:rPr>
+              <a:t>As₁</a:t>
+            </a:r>
+          </a:p>
+        </p:txBody>
+      </p:sp>
+      <p:sp>
+        <p:nvSpPr>
+          <p:cNvPr id="10" name="Oval 9"/>
+          <p:cNvSpPr/>
+          <p:nvPr/>
+        </p:nvSpPr>
+        <p:spPr>
+          <a:xfrm>
+            <a:off x="4163568" y="2226564"/>
+            <a:ext cx="768096" cy="768096"/>
+          </a:xfrm>
+          <a:prstGeom prst="ellipse">
+            <a:avLst/>
+          </a:prstGeom>
+          <a:noFill/>
+          <a:ln w="22225">
+            <a:solidFill>
+              <a:srgbClr val="B8860B"/>
+            </a:solidFill>
+            <a:prstDash val="dash"/>
+          </a:ln>
+          <a:effectLst/>
+        </p:spPr>
+        <p:style>
+          <a:lnRef idx="1">
+            <a:schemeClr val="accent1"/>
+          </a:lnRef>
+          <a:fillRef idx="3">
+            <a:schemeClr val="accent1"/>
+          </a:fillRef>
+          <a:effectRef idx="2">
+            <a:schemeClr val="accent1"/>
+          </a:effectRef>
+          <a:fontRef idx="minor">
+            <a:schemeClr val="lt1"/>
+          </a:fontRef>
+        </p:style>
+        <p:txBody>
+          <a:bodyPr rtlCol="0" anchor="ctr"/>
+          <a:lstStyle/>
+          <a:p>
+            <a:pPr algn="ctr"/>
+          </a:p>
+        </p:txBody>
+      </p:sp>
+      <p:sp>
+        <p:nvSpPr>
+          <p:cNvPr id="11" name="Oval 10"/>
+          <p:cNvSpPr/>
+          <p:nvPr/>
+        </p:nvSpPr>
+        <p:spPr>
+          <a:xfrm>
+            <a:off x="4506468" y="2569464"/>
+            <a:ext cx="82296" cy="82296"/>
+          </a:xfrm>
+          <a:prstGeom prst="ellipse">
+            <a:avLst/>
+          </a:prstGeom>
+          <a:solidFill>
+            <a:srgbClr val="B3361E"/>
+          </a:solidFill>
+          <a:ln>
+            <a:solidFill>
+              <a:srgbClr val="B3361E"/>
+            </a:solidFill>
+          </a:ln>
+          <a:effectLst/>
+        </p:spPr>
+        <p:style>
+          <a:lnRef idx="1">
+            <a:schemeClr val="accent1"/>
+          </a:lnRef>
+          <a:fillRef idx="3">
+            <a:schemeClr val="accent1"/>
+          </a:fillRef>
+          <a:effectRef idx="2">
+            <a:schemeClr val="accent1"/>
+          </a:effectRef>
+          <a:fontRef idx="minor">
+            <a:schemeClr val="lt1"/>
+          </a:fontRef>
+        </p:style>
+        <p:txBody>
+          <a:bodyPr rtlCol="0" anchor="ctr"/>
+          <a:lstStyle/>
+          <a:p>
+            <a:pPr algn="ctr"/>
+          </a:p>
+        </p:txBody>
+      </p:sp>
+      <p:sp>
+        <p:nvSpPr>
+          <p:cNvPr id="12" name="TextBox 11"/>
+          <p:cNvSpPr txBox="1"/>
+          <p:nvPr/>
+        </p:nvSpPr>
+        <p:spPr>
+          <a:xfrm>
+            <a:off x="4044696" y="1915668"/>
+            <a:ext cx="1005840" cy="274320"/>
+          </a:xfrm>
+          <a:prstGeom prst="rect">
+            <a:avLst/>
+          </a:prstGeom>
+          <a:noFill/>
+        </p:spPr>
+        <p:txBody>
+          <a:bodyPr wrap="square" anchor="t" lIns="0" rIns="0" tIns="0" bIns="0">
+            <a:spAutoFit/>
+          </a:bodyPr>
+          <a:lstStyle/>
+          <a:p>
+            <a:pPr algn="ctr">
+              <a:lnSpc>
+                <a:spcPct val="115000"/>
+              </a:lnSpc>
+            </a:pPr>
+            <a:r>
+              <a:rPr sz="1300" b="0" i="1">
+                <a:solidFill>
+                  <a:srgbClr val="222222"/>
+                </a:solidFill>
+                <a:latin typeface="맑은 고딕"/>
+              </a:rPr>
+              <a:t>As₂</a:t>
+            </a:r>
+          </a:p>
+        </p:txBody>
+      </p:sp>
+      <p:sp>
+        <p:nvSpPr>
+          <p:cNvPr id="13" name="Oval 12"/>
+          <p:cNvSpPr/>
+          <p:nvPr/>
+        </p:nvSpPr>
+        <p:spPr>
+          <a:xfrm>
+            <a:off x="7229856" y="1714500"/>
+            <a:ext cx="768096" cy="768096"/>
+          </a:xfrm>
+          <a:prstGeom prst="ellipse">
+            <a:avLst/>
+          </a:prstGeom>
+          <a:noFill/>
+          <a:ln w="22225">
+            <a:solidFill>
+              <a:srgbClr val="B8860B"/>
+            </a:solidFill>
+            <a:prstDash val="dash"/>
+          </a:ln>
+          <a:effectLst/>
+        </p:spPr>
+        <p:style>
+          <a:lnRef idx="1">
+            <a:schemeClr val="accent1"/>
+          </a:lnRef>
+          <a:fillRef idx="3">
+            <a:schemeClr val="accent1"/>
+          </a:fillRef>
+          <a:effectRef idx="2">
+            <a:schemeClr val="accent1"/>
+          </a:effectRef>
+          <a:fontRef idx="minor">
+            <a:schemeClr val="lt1"/>
+          </a:fontRef>
+        </p:style>
+        <p:txBody>
+          <a:bodyPr rtlCol="0" anchor="ctr"/>
+          <a:lstStyle/>
+          <a:p>
+            <a:pPr algn="ctr"/>
+          </a:p>
+        </p:txBody>
+      </p:sp>
+      <p:sp>
+        <p:nvSpPr>
+          <p:cNvPr id="14" name="Oval 13"/>
+          <p:cNvSpPr/>
+          <p:nvPr/>
+        </p:nvSpPr>
+        <p:spPr>
+          <a:xfrm>
+            <a:off x="7572756" y="2057400"/>
+            <a:ext cx="82296" cy="82296"/>
+          </a:xfrm>
+          <a:prstGeom prst="ellipse">
+            <a:avLst/>
+          </a:prstGeom>
+          <a:solidFill>
+            <a:srgbClr val="B3361E"/>
+          </a:solidFill>
+          <a:ln>
+            <a:solidFill>
+              <a:srgbClr val="B3361E"/>
+            </a:solidFill>
+          </a:ln>
+          <a:effectLst/>
+        </p:spPr>
+        <p:style>
+          <a:lnRef idx="1">
+            <a:schemeClr val="accent1"/>
+          </a:lnRef>
+          <a:fillRef idx="3">
+            <a:schemeClr val="accent1"/>
+          </a:fillRef>
+          <a:effectRef idx="2">
+            <a:schemeClr val="accent1"/>
+          </a:effectRef>
+          <a:fontRef idx="minor">
+            <a:schemeClr val="lt1"/>
+          </a:fontRef>
+        </p:style>
+        <p:txBody>
+          <a:bodyPr rtlCol="0" anchor="ctr"/>
+          <a:lstStyle/>
+          <a:p>
+            <a:pPr algn="ctr"/>
+          </a:p>
+        </p:txBody>
+      </p:sp>
+      <p:sp>
+        <p:nvSpPr>
+          <p:cNvPr id="15" name="TextBox 14"/>
+          <p:cNvSpPr txBox="1"/>
+          <p:nvPr/>
+        </p:nvSpPr>
+        <p:spPr>
+          <a:xfrm>
+            <a:off x="7110984" y="1403604"/>
+            <a:ext cx="1005840" cy="274320"/>
+          </a:xfrm>
+          <a:prstGeom prst="rect">
+            <a:avLst/>
+          </a:prstGeom>
+          <a:noFill/>
+        </p:spPr>
+        <p:txBody>
+          <a:bodyPr wrap="square" anchor="t" lIns="0" rIns="0" tIns="0" bIns="0">
+            <a:spAutoFit/>
+          </a:bodyPr>
+          <a:lstStyle/>
+          <a:p>
+            <a:pPr algn="ctr">
+              <a:lnSpc>
+                <a:spcPct val="115000"/>
+              </a:lnSpc>
+            </a:pPr>
+            <a:r>
+              <a:rPr sz="1300" b="0" i="1">
+                <a:solidFill>
+                  <a:srgbClr val="222222"/>
+                </a:solidFill>
+                <a:latin typeface="맑은 고딕"/>
+              </a:rPr>
+              <a:t>As₃</a:t>
+            </a:r>
+          </a:p>
+        </p:txBody>
+      </p:sp>
+      <p:sp>
+        <p:nvSpPr>
+          <p:cNvPr id="16" name="Oval 15"/>
+          <p:cNvSpPr/>
+          <p:nvPr/>
+        </p:nvSpPr>
+        <p:spPr>
+          <a:xfrm>
+            <a:off x="10296144" y="2226564"/>
+            <a:ext cx="768096" cy="768096"/>
+          </a:xfrm>
+          <a:prstGeom prst="ellipse">
+            <a:avLst/>
+          </a:prstGeom>
+          <a:noFill/>
+          <a:ln w="22225">
+            <a:solidFill>
+              <a:srgbClr val="B8860B"/>
+            </a:solidFill>
+            <a:prstDash val="dash"/>
+          </a:ln>
+          <a:effectLst/>
+        </p:spPr>
+        <p:style>
+          <a:lnRef idx="1">
+            <a:schemeClr val="accent1"/>
+          </a:lnRef>
+          <a:fillRef idx="3">
+            <a:schemeClr val="accent1"/>
+          </a:fillRef>
+          <a:effectRef idx="2">
+            <a:schemeClr val="accent1"/>
+          </a:effectRef>
+          <a:fontRef idx="minor">
+            <a:schemeClr val="lt1"/>
+          </a:fontRef>
+        </p:style>
+        <p:txBody>
+          <a:bodyPr rtlCol="0" anchor="ctr"/>
+          <a:lstStyle/>
+          <a:p>
+            <a:pPr algn="ctr"/>
+          </a:p>
+        </p:txBody>
+      </p:sp>
+      <p:sp>
+        <p:nvSpPr>
+          <p:cNvPr id="17" name="Oval 16"/>
+          <p:cNvSpPr/>
+          <p:nvPr/>
+        </p:nvSpPr>
+        <p:spPr>
+          <a:xfrm>
+            <a:off x="10639044" y="2569464"/>
+            <a:ext cx="82296" cy="82296"/>
+          </a:xfrm>
+          <a:prstGeom prst="ellipse">
+            <a:avLst/>
+          </a:prstGeom>
+          <a:solidFill>
+            <a:srgbClr val="B3361E"/>
+          </a:solidFill>
+          <a:ln>
+            <a:solidFill>
+              <a:srgbClr val="B3361E"/>
+            </a:solidFill>
+          </a:ln>
+          <a:effectLst/>
+        </p:spPr>
+        <p:style>
+          <a:lnRef idx="1">
+            <a:schemeClr val="accent1"/>
+          </a:lnRef>
+          <a:fillRef idx="3">
+            <a:schemeClr val="accent1"/>
+          </a:fillRef>
+          <a:effectRef idx="2">
+            <a:schemeClr val="accent1"/>
+          </a:effectRef>
+          <a:fontRef idx="minor">
+            <a:schemeClr val="lt1"/>
+          </a:fontRef>
+        </p:style>
+        <p:txBody>
+          <a:bodyPr rtlCol="0" anchor="ctr"/>
+          <a:lstStyle/>
+          <a:p>
+            <a:pPr algn="ctr"/>
+          </a:p>
+        </p:txBody>
+      </p:sp>
+      <p:sp>
+        <p:nvSpPr>
+          <p:cNvPr id="18" name="TextBox 17"/>
+          <p:cNvSpPr txBox="1"/>
+          <p:nvPr/>
+        </p:nvSpPr>
+        <p:spPr>
+          <a:xfrm>
+            <a:off x="10177272" y="1915668"/>
+            <a:ext cx="1005840" cy="274320"/>
+          </a:xfrm>
+          <a:prstGeom prst="rect">
+            <a:avLst/>
+          </a:prstGeom>
+          <a:noFill/>
+        </p:spPr>
+        <p:txBody>
+          <a:bodyPr wrap="square" anchor="t" lIns="0" rIns="0" tIns="0" bIns="0">
+            <a:spAutoFit/>
+          </a:bodyPr>
+          <a:lstStyle/>
+          <a:p>
+            <a:pPr algn="ctr">
+              <a:lnSpc>
+                <a:spcPct val="115000"/>
+              </a:lnSpc>
+            </a:pPr>
+            <a:r>
+              <a:rPr sz="1300" b="0" i="1">
+                <a:solidFill>
+                  <a:srgbClr val="222222"/>
+                </a:solidFill>
+                <a:latin typeface="맑은 고딕"/>
+              </a:rPr>
+              <a:t>As₄</a:t>
+            </a:r>
+          </a:p>
+        </p:txBody>
+      </p:sp>
+      <p:sp>
+        <p:nvSpPr>
+          <p:cNvPr id="19" name="TextBox 18"/>
+          <p:cNvSpPr txBox="1"/>
+          <p:nvPr/>
+        </p:nvSpPr>
+        <p:spPr>
+          <a:xfrm>
+            <a:off x="1051560" y="2980944"/>
+            <a:ext cx="10058400" cy="274320"/>
+          </a:xfrm>
+          <a:prstGeom prst="rect">
+            <a:avLst/>
+          </a:prstGeom>
+          <a:noFill/>
+        </p:spPr>
+        <p:txBody>
+          <a:bodyPr wrap="square" anchor="t" lIns="0" rIns="0" tIns="0" bIns="0">
+            <a:spAutoFit/>
+          </a:bodyPr>
+          <a:lstStyle/>
+          <a:p>
+            <a:pPr algn="ctr">
+              <a:lnSpc>
+                <a:spcPct val="115000"/>
+              </a:lnSpc>
+            </a:pPr>
+            <a:r>
+              <a:rPr sz="1150" b="0" i="0">
+                <a:solidFill>
+                  <a:srgbClr val="5A5A5A"/>
+                </a:solidFill>
+                <a:latin typeface="맑은 고딕"/>
+              </a:rPr>
+              <a:t>점선 원 = 잡음 반경 B 안의 후보들 (겹치면 유일성이 깨짐)</a:t>
+            </a:r>
+          </a:p>
+        </p:txBody>
+      </p:sp>
+      <p:sp>
+        <p:nvSpPr>
+          <p:cNvPr id="20" name="TextBox 19"/>
+          <p:cNvSpPr txBox="1"/>
+          <p:nvPr/>
+        </p:nvSpPr>
+        <p:spPr>
+          <a:xfrm>
+            <a:off x="685800" y="3566160"/>
+            <a:ext cx="10789920" cy="3108960"/>
           </a:xfrm>
           <a:prstGeom prst="rect">
             <a:avLst/>
@@ -9604,17 +10632,17 @@
                 <a:spcPct val="125000"/>
               </a:lnSpc>
               <a:spcAft>
-                <a:spcPts val="1600"/>
+                <a:spcPts val="900"/>
               </a:spcAft>
             </a:pPr>
             <a:r>
-              <a:rPr sz="1950">
+              <a:rPr sz="1650">
                 <a:solidFill>
                   <a:srgbClr val="222222"/>
                 </a:solidFill>
                 <a:latin typeface="맑은 고딕"/>
               </a:rPr>
-              <a:t>—  LWE(탐색): (A,b)에서 정확한 비밀 s를 찾아라</a:t>
+              <a:t>—  DLWE(m,n,q,B): A∈R ℤq^(m×n), s∈R ℤqⁿ, e∈R[-B,B]ᵐ, r∈R ℤqᵐ, b=As+e — 확률 ½로 c=b, 확률 ½로 c=r</a:t>
             </a:r>
           </a:p>
           <a:p>
@@ -9623,17 +10651,17 @@
                 <a:spcPct val="125000"/>
               </a:lnSpc>
               <a:spcAft>
-                <a:spcPts val="1600"/>
+                <a:spcPts val="900"/>
               </a:spcAft>
             </a:pPr>
             <a:r>
-              <a:rPr sz="1950">
+              <a:rPr sz="1650">
                 <a:solidFill>
                   <a:srgbClr val="222222"/>
                 </a:solidFill>
                 <a:latin typeface="맑은 고딕"/>
               </a:rPr>
-              <a:t>—  DLWE(결정): (A,c)가 진짜 LWE 표본(c=As+e)인지, 완전히 무작위(c=r)인지만 구별하라</a:t>
+              <a:t>—  LWE(탐색): (A,b)에서 정확한 비밀 s를 찾아라 / DLWE(결정): (A,c)가 위 구들 중 하나에 속하는(c=b) 표본인지, 완전히 무작위(c=r)인지만 구별하라</a:t>
             </a:r>
           </a:p>
           <a:p>
@@ -9642,11 +10670,11 @@
                 <a:spcPct val="125000"/>
               </a:lnSpc>
               <a:spcAft>
-                <a:spcPts val="1600"/>
+                <a:spcPts val="900"/>
               </a:spcAft>
             </a:pPr>
             <a:r>
-              <a:rPr sz="1950">
+              <a:rPr sz="1650">
                 <a:solidFill>
                   <a:srgbClr val="222222"/>
                 </a:solidFill>
@@ -9661,11 +10689,11 @@
                 <a:spcPct val="125000"/>
               </a:lnSpc>
               <a:spcAft>
-                <a:spcPts val="1600"/>
+                <a:spcPts val="900"/>
               </a:spcAft>
             </a:pPr>
             <a:r>
-              <a:rPr sz="1950">
+              <a:rPr sz="1650">
                 <a:solidFill>
                   <a:srgbClr val="222222"/>
                 </a:solidFill>
@@ -10454,16 +11482,212 @@
           </a:p>
         </p:txBody>
       </p:sp>
-      <p:sp>
-        <p:nvSpPr>
-          <p:cNvPr id="6" name="TextBox 5"/>
-          <p:cNvSpPr txBox="1"/>
-          <p:nvPr/>
-        </p:nvSpPr>
-        <p:spPr>
-          <a:xfrm>
-            <a:off x="685800" y="1463040"/>
-            <a:ext cx="10789920" cy="4572000"/>
+      <p:cxnSp>
+        <p:nvCxnSpPr>
+          <p:cNvPr id="6" name="Connector 5"/>
+          <p:cNvCxnSpPr/>
+          <p:nvPr/>
+        </p:nvCxnSpPr>
+        <p:spPr>
+          <a:xfrm>
+            <a:off x="3108960" y="1805940"/>
+            <a:ext cx="5943600" cy="0"/>
+          </a:xfrm>
+          <a:prstGeom prst="line">
+            <a:avLst/>
+          </a:prstGeom>
+          <a:ln w="19050">
+            <a:solidFill>
+              <a:srgbClr val="C7CBD3"/>
+            </a:solidFill>
+          </a:ln>
+        </p:spPr>
+        <p:style>
+          <a:lnRef idx="2">
+            <a:schemeClr val="accent1"/>
+          </a:lnRef>
+          <a:fillRef idx="0">
+            <a:schemeClr val="accent1"/>
+          </a:fillRef>
+          <a:effectRef idx="1">
+            <a:schemeClr val="accent1"/>
+          </a:effectRef>
+          <a:fontRef idx="minor">
+            <a:schemeClr val="tx1"/>
+          </a:fontRef>
+        </p:style>
+      </p:cxnSp>
+      <p:sp>
+        <p:nvSpPr>
+          <p:cNvPr id="7" name="Rectangle 6"/>
+          <p:cNvSpPr/>
+          <p:nvPr/>
+        </p:nvSpPr>
+        <p:spPr>
+          <a:xfrm>
+            <a:off x="5605272" y="1723644"/>
+            <a:ext cx="950976" cy="164592"/>
+          </a:xfrm>
+          <a:prstGeom prst="rect">
+            <a:avLst/>
+          </a:prstGeom>
+          <a:solidFill>
+            <a:srgbClr val="B3361E"/>
+          </a:solidFill>
+          <a:ln>
+            <a:noFill/>
+          </a:ln>
+          <a:effectLst/>
+        </p:spPr>
+        <p:style>
+          <a:lnRef idx="1">
+            <a:schemeClr val="accent1"/>
+          </a:lnRef>
+          <a:fillRef idx="3">
+            <a:schemeClr val="accent1"/>
+          </a:fillRef>
+          <a:effectRef idx="2">
+            <a:schemeClr val="accent1"/>
+          </a:effectRef>
+          <a:fontRef idx="minor">
+            <a:schemeClr val="lt1"/>
+          </a:fontRef>
+        </p:style>
+        <p:txBody>
+          <a:bodyPr rtlCol="0" anchor="ctr"/>
+          <a:lstStyle/>
+          <a:p>
+            <a:pPr algn="ctr"/>
+          </a:p>
+        </p:txBody>
+      </p:sp>
+      <p:sp>
+        <p:nvSpPr>
+          <p:cNvPr id="8" name="TextBox 7"/>
+          <p:cNvSpPr txBox="1"/>
+          <p:nvPr/>
+        </p:nvSpPr>
+        <p:spPr>
+          <a:xfrm>
+            <a:off x="5605272" y="1943100"/>
+            <a:ext cx="950976" cy="320040"/>
+          </a:xfrm>
+          <a:prstGeom prst="rect">
+            <a:avLst/>
+          </a:prstGeom>
+          <a:noFill/>
+        </p:spPr>
+        <p:txBody>
+          <a:bodyPr wrap="square" anchor="t" lIns="0" rIns="0" tIns="0" bIns="0">
+            <a:spAutoFit/>
+          </a:bodyPr>
+          <a:lstStyle/>
+          <a:p>
+            <a:pPr algn="ctr">
+              <a:lnSpc>
+                <a:spcPct val="115000"/>
+              </a:lnSpc>
+            </a:pPr>
+            <a:r>
+              <a:rPr sz="1300" b="0" i="0">
+                <a:solidFill>
+                  <a:srgbClr val="5A5A5A"/>
+                </a:solidFill>
+                <a:latin typeface="맑은 고딕"/>
+              </a:rPr>
+              <a:t>sᵢ ∈ [-B,B]</a:t>
+            </a:r>
+          </a:p>
+        </p:txBody>
+      </p:sp>
+      <p:sp>
+        <p:nvSpPr>
+          <p:cNvPr id="9" name="TextBox 8"/>
+          <p:cNvSpPr txBox="1"/>
+          <p:nvPr/>
+        </p:nvSpPr>
+        <p:spPr>
+          <a:xfrm>
+            <a:off x="2971800" y="1554480"/>
+            <a:ext cx="822960" cy="274320"/>
+          </a:xfrm>
+          <a:prstGeom prst="rect">
+            <a:avLst/>
+          </a:prstGeom>
+          <a:noFill/>
+        </p:spPr>
+        <p:txBody>
+          <a:bodyPr wrap="square" anchor="t" lIns="0" rIns="0" tIns="0" bIns="0">
+            <a:spAutoFit/>
+          </a:bodyPr>
+          <a:lstStyle/>
+          <a:p>
+            <a:pPr algn="l">
+              <a:lnSpc>
+                <a:spcPct val="115000"/>
+              </a:lnSpc>
+            </a:pPr>
+            <a:r>
+              <a:rPr sz="1400" b="0" i="1">
+                <a:solidFill>
+                  <a:srgbClr val="222222"/>
+                </a:solidFill>
+                <a:latin typeface="맑은 고딕"/>
+              </a:rPr>
+              <a:t>-q</a:t>
+            </a:r>
+          </a:p>
+        </p:txBody>
+      </p:sp>
+      <p:sp>
+        <p:nvSpPr>
+          <p:cNvPr id="10" name="TextBox 9"/>
+          <p:cNvSpPr txBox="1"/>
+          <p:nvPr/>
+        </p:nvSpPr>
+        <p:spPr>
+          <a:xfrm>
+            <a:off x="8366760" y="1554480"/>
+            <a:ext cx="822960" cy="274320"/>
+          </a:xfrm>
+          <a:prstGeom prst="rect">
+            <a:avLst/>
+          </a:prstGeom>
+          <a:noFill/>
+        </p:spPr>
+        <p:txBody>
+          <a:bodyPr wrap="square" anchor="t" lIns="0" rIns="0" tIns="0" bIns="0">
+            <a:spAutoFit/>
+          </a:bodyPr>
+          <a:lstStyle/>
+          <a:p>
+            <a:pPr algn="r">
+              <a:lnSpc>
+                <a:spcPct val="115000"/>
+              </a:lnSpc>
+            </a:pPr>
+            <a:r>
+              <a:rPr sz="1400" b="0" i="1">
+                <a:solidFill>
+                  <a:srgbClr val="222222"/>
+                </a:solidFill>
+                <a:latin typeface="맑은 고딕"/>
+              </a:rPr>
+              <a:t>q</a:t>
+            </a:r>
+          </a:p>
+        </p:txBody>
+      </p:sp>
+      <p:sp>
+        <p:nvSpPr>
+          <p:cNvPr id="11" name="TextBox 10"/>
+          <p:cNvSpPr txBox="1"/>
+          <p:nvPr/>
+        </p:nvSpPr>
+        <p:spPr>
+          <a:xfrm>
+            <a:off x="685800" y="2606040"/>
+            <a:ext cx="10789920" cy="3566160"/>
           </a:xfrm>
           <a:prstGeom prst="rect">
             <a:avLst/>
@@ -10481,17 +11705,17 @@
                 <a:spcPct val="125000"/>
               </a:lnSpc>
               <a:spcAft>
-                <a:spcPts val="1600"/>
+                <a:spcPts val="1100"/>
               </a:spcAft>
             </a:pPr>
             <a:r>
-              <a:rPr sz="1950">
+              <a:rPr sz="1750">
                 <a:solidFill>
                   <a:srgbClr val="222222"/>
                 </a:solidFill>
                 <a:latin typeface="맑은 고딕"/>
               </a:rPr>
-              <a:t>—  비밀 s도 오차 e처럼 [-B,B]ⁿ 에서 뽑는 LWE 변형</a:t>
+              <a:t>—  비밀 s도 오차 e처럼 [-B,B]ⁿ 에서 뽑는 LWE 변형 — b=As+e (mod q), (A,b)에서 s 찾기</a:t>
             </a:r>
           </a:p>
           <a:p>
@@ -10500,11 +11724,11 @@
                 <a:spcPct val="125000"/>
               </a:lnSpc>
               <a:spcAft>
-                <a:spcPts val="1600"/>
+                <a:spcPts val="1100"/>
               </a:spcAft>
             </a:pPr>
             <a:r>
-              <a:rPr sz="1950">
+              <a:rPr sz="1750">
                 <a:solidFill>
                   <a:srgbClr val="222222"/>
                 </a:solidFill>
@@ -10519,11 +11743,11 @@
                 <a:spcPct val="125000"/>
               </a:lnSpc>
               <a:spcAft>
-                <a:spcPts val="1600"/>
+                <a:spcPts val="1100"/>
               </a:spcAft>
             </a:pPr>
             <a:r>
-              <a:rPr sz="1950">
+              <a:rPr sz="1750">
                 <a:solidFill>
                   <a:srgbClr val="222222"/>
                 </a:solidFill>
@@ -10538,11 +11762,11 @@
                 <a:spcPct val="125000"/>
               </a:lnSpc>
               <a:spcAft>
-                <a:spcPts val="1600"/>
+                <a:spcPts val="1100"/>
               </a:spcAft>
             </a:pPr>
             <a:r>
-              <a:rPr sz="1950">
+              <a:rPr sz="1750">
                 <a:solidFill>
                   <a:srgbClr val="222222"/>
                 </a:solidFill>
@@ -13024,8 +14248,8 @@
         </p:nvSpPr>
         <p:spPr>
           <a:xfrm>
-            <a:off x="685800" y="1417320"/>
-            <a:ext cx="10789920" cy="1463040"/>
+            <a:off x="685800" y="1371600"/>
+            <a:ext cx="10789920" cy="2194560"/>
           </a:xfrm>
           <a:prstGeom prst="rect">
             <a:avLst/>
@@ -13043,17 +14267,17 @@
                 <a:spcPct val="125000"/>
               </a:lnSpc>
               <a:spcAft>
-                <a:spcPts val="1000"/>
+                <a:spcPts val="900"/>
               </a:spcAft>
             </a:pPr>
             <a:r>
-              <a:rPr sz="1900">
+              <a:rPr sz="1850">
                 <a:solidFill>
                   <a:srgbClr val="222222"/>
                 </a:solidFill>
                 <a:latin typeface="맑은 고딕"/>
               </a:rPr>
-              <a:t>—  ℤq = {0,1,…,q-1} (q는 소수), 모든 벡터는 열벡터</a:t>
+              <a:t>—  ℤq = {0,1,…,q-1} (q는 소수), 모든 벡터는 열벡터(column vector)로 취급</a:t>
             </a:r>
           </a:p>
           <a:p>
@@ -13062,16 +14286,35 @@
                 <a:spcPct val="125000"/>
               </a:lnSpc>
               <a:spcAft>
-                <a:spcPts val="1000"/>
+                <a:spcPts val="900"/>
               </a:spcAft>
             </a:pPr>
             <a:r>
-              <a:rPr sz="1900">
+              <a:rPr sz="1850">
                 <a:solidFill>
                   <a:srgbClr val="222222"/>
                 </a:solidFill>
                 <a:latin typeface="맑은 고딕"/>
               </a:rPr>
+              <a:t>—  x ∈R S : x가 집합 S에서 균등(uniform)·독립적으로 무작위 선택됨을 뜻함</a:t>
+            </a:r>
+          </a:p>
+          <a:p>
+            <a:pPr>
+              <a:lnSpc>
+                <a:spcPct val="125000"/>
+              </a:lnSpc>
+              <a:spcAft>
+                <a:spcPts val="900"/>
+              </a:spcAft>
+            </a:pPr>
+            <a:r>
+              <a:rPr sz="1850">
+                <a:solidFill>
+                  <a:srgbClr val="222222"/>
+                </a:solidFill>
+                <a:latin typeface="맑은 고딕"/>
+              </a:rPr>
               <a:t>—  행렬-벡터 곱 Az: A의 i번째 행과 z의 내적 — (Az)ᵢ = Σⱼ Aᵢⱼzⱼ</a:t>
             </a:r>
           </a:p>
@@ -13085,7 +14328,7 @@
         </p:nvSpPr>
         <p:spPr>
           <a:xfrm>
-            <a:off x="1097280" y="3108960"/>
+            <a:off x="1097280" y="3429000"/>
             <a:ext cx="8229600" cy="1463040"/>
           </a:xfrm>
           <a:prstGeom prst="rect">
@@ -13132,7 +14375,7 @@
         </p:nvSpPr>
         <p:spPr>
           <a:xfrm>
-            <a:off x="685800" y="4892040"/>
+            <a:off x="685800" y="5212080"/>
             <a:ext cx="10789920" cy="1097280"/>
           </a:xfrm>
           <a:prstGeom prst="rect">
@@ -14869,16 +16112,16 @@
         </p:nvSpPr>
         <p:spPr>
           <a:xfrm>
-            <a:off x="3327044" y="2999232"/>
-            <a:ext cx="1247241" cy="274320"/>
-          </a:xfrm>
-          <a:prstGeom prst="rect">
-            <a:avLst/>
-          </a:prstGeom>
-          <a:noFill/>
-        </p:spPr>
-        <p:txBody>
-          <a:bodyPr wrap="square" anchor="t" lIns="0" rIns="0" tIns="0" bIns="0">
+            <a:off x="3007004" y="2999232"/>
+            <a:ext cx="1887321" cy="274320"/>
+          </a:xfrm>
+          <a:prstGeom prst="rect">
+            <a:avLst/>
+          </a:prstGeom>
+          <a:noFill/>
+        </p:spPr>
+        <p:txBody>
+          <a:bodyPr wrap="none" anchor="t" lIns="0" rIns="0" tIns="0" bIns="0">
             <a:spAutoFit/>
           </a:bodyPr>
           <a:lstStyle/>
@@ -15002,16 +16245,16 @@
         </p:nvSpPr>
         <p:spPr>
           <a:xfrm>
-            <a:off x="5479542" y="2999232"/>
-            <a:ext cx="453542" cy="274320"/>
-          </a:xfrm>
-          <a:prstGeom prst="rect">
-            <a:avLst/>
-          </a:prstGeom>
-          <a:noFill/>
-        </p:spPr>
-        <p:txBody>
-          <a:bodyPr wrap="square" anchor="t" lIns="0" rIns="0" tIns="0" bIns="0">
+            <a:off x="5159502" y="2999232"/>
+            <a:ext cx="1093622" cy="274320"/>
+          </a:xfrm>
+          <a:prstGeom prst="rect">
+            <a:avLst/>
+          </a:prstGeom>
+          <a:noFill/>
+        </p:spPr>
+        <p:txBody>
+          <a:bodyPr wrap="none" anchor="t" lIns="0" rIns="0" tIns="0" bIns="0">
             <a:spAutoFit/>
           </a:bodyPr>
           <a:lstStyle/>
@@ -15135,16 +16378,16 @@
         </p:nvSpPr>
         <p:spPr>
           <a:xfrm>
-            <a:off x="6838340" y="2999232"/>
-            <a:ext cx="453542" cy="274320"/>
-          </a:xfrm>
-          <a:prstGeom prst="rect">
-            <a:avLst/>
-          </a:prstGeom>
-          <a:noFill/>
-        </p:spPr>
-        <p:txBody>
-          <a:bodyPr wrap="square" anchor="t" lIns="0" rIns="0" tIns="0" bIns="0">
+            <a:off x="6518300" y="2999232"/>
+            <a:ext cx="1093622" cy="274320"/>
+          </a:xfrm>
+          <a:prstGeom prst="rect">
+            <a:avLst/>
+          </a:prstGeom>
+          <a:noFill/>
+        </p:spPr>
+        <p:txBody>
+          <a:bodyPr wrap="none" anchor="t" lIns="0" rIns="0" tIns="0" bIns="0">
             <a:spAutoFit/>
           </a:bodyPr>
           <a:lstStyle/>
@@ -15937,14 +17180,413 @@
       </p:sp>
       <p:sp>
         <p:nvSpPr>
-          <p:cNvPr id="6" name="TextBox 5"/>
-          <p:cNvSpPr txBox="1"/>
-          <p:nvPr/>
-        </p:nvSpPr>
-        <p:spPr>
-          <a:xfrm>
-            <a:off x="685800" y="1463040"/>
-            <a:ext cx="10789920" cy="4206240"/>
+          <p:cNvPr id="6" name="Rectangle 5"/>
+          <p:cNvSpPr/>
+          <p:nvPr/>
+        </p:nvSpPr>
+        <p:spPr>
+          <a:xfrm>
+            <a:off x="3616909" y="1280160"/>
+            <a:ext cx="963777" cy="822960"/>
+          </a:xfrm>
+          <a:prstGeom prst="rect">
+            <a:avLst/>
+          </a:prstGeom>
+          <a:solidFill>
+            <a:srgbClr val="F4F5F7"/>
+          </a:solidFill>
+          <a:ln w="15875">
+            <a:solidFill>
+              <a:srgbClr val="C7CBD3"/>
+            </a:solidFill>
+          </a:ln>
+          <a:effectLst/>
+        </p:spPr>
+        <p:style>
+          <a:lnRef idx="1">
+            <a:schemeClr val="accent1"/>
+          </a:lnRef>
+          <a:fillRef idx="3">
+            <a:schemeClr val="accent1"/>
+          </a:fillRef>
+          <a:effectRef idx="2">
+            <a:schemeClr val="accent1"/>
+          </a:effectRef>
+          <a:fontRef idx="minor">
+            <a:schemeClr val="lt1"/>
+          </a:fontRef>
+        </p:style>
+        <p:txBody>
+          <a:bodyPr rtlCol="0" anchor="ctr" wrap="square"/>
+          <a:lstStyle/>
+          <a:p>
+            <a:pPr algn="ctr"/>
+            <a:r>
+              <a:rPr sz="1900" b="0" i="1">
+                <a:solidFill>
+                  <a:srgbClr val="222222"/>
+                </a:solidFill>
+                <a:latin typeface="Cambria Math"/>
+              </a:rPr>
+              <a:t>A</a:t>
+            </a:r>
+          </a:p>
+        </p:txBody>
+      </p:sp>
+      <p:sp>
+        <p:nvSpPr>
+          <p:cNvPr id="7" name="TextBox 6"/>
+          <p:cNvSpPr txBox="1"/>
+          <p:nvPr/>
+        </p:nvSpPr>
+        <p:spPr>
+          <a:xfrm>
+            <a:off x="3296869" y="2130552"/>
+            <a:ext cx="1603857" cy="274320"/>
+          </a:xfrm>
+          <a:prstGeom prst="rect">
+            <a:avLst/>
+          </a:prstGeom>
+          <a:noFill/>
+        </p:spPr>
+        <p:txBody>
+          <a:bodyPr wrap="none" anchor="t" lIns="0" rIns="0" tIns="0" bIns="0">
+            <a:spAutoFit/>
+          </a:bodyPr>
+          <a:lstStyle/>
+          <a:p>
+            <a:pPr algn="ctr">
+              <a:lnSpc>
+                <a:spcPct val="115000"/>
+              </a:lnSpc>
+            </a:pPr>
+            <a:r>
+              <a:rPr sz="1200" b="0" i="1">
+                <a:solidFill>
+                  <a:srgbClr val="5A5A5A"/>
+                </a:solidFill>
+                <a:latin typeface="맑은 고딕"/>
+              </a:rPr>
+              <a:t>n × m</a:t>
+            </a:r>
+          </a:p>
+        </p:txBody>
+      </p:sp>
+      <p:sp>
+        <p:nvSpPr>
+          <p:cNvPr id="8" name="TextBox 7"/>
+          <p:cNvSpPr txBox="1"/>
+          <p:nvPr/>
+        </p:nvSpPr>
+        <p:spPr>
+          <a:xfrm>
+            <a:off x="4781854" y="1280160"/>
+            <a:ext cx="457200" cy="822960"/>
+          </a:xfrm>
+          <a:prstGeom prst="rect">
+            <a:avLst/>
+          </a:prstGeom>
+          <a:noFill/>
+        </p:spPr>
+        <p:txBody>
+          <a:bodyPr wrap="square" anchor="ctr" lIns="0" rIns="0" tIns="0" bIns="0">
+            <a:spAutoFit/>
+          </a:bodyPr>
+          <a:lstStyle/>
+          <a:p>
+            <a:pPr algn="ctr">
+              <a:lnSpc>
+                <a:spcPct val="115000"/>
+              </a:lnSpc>
+            </a:pPr>
+            <a:r>
+              <a:rPr sz="2500" b="0" i="0">
+                <a:solidFill>
+                  <a:srgbClr val="222222"/>
+                </a:solidFill>
+                <a:latin typeface="맑은 고딕"/>
+              </a:rPr>
+              <a:t/>
+            </a:r>
+          </a:p>
+        </p:txBody>
+      </p:sp>
+      <p:sp>
+        <p:nvSpPr>
+          <p:cNvPr id="9" name="Rectangle 8"/>
+          <p:cNvSpPr/>
+          <p:nvPr/>
+        </p:nvSpPr>
+        <p:spPr>
+          <a:xfrm>
+            <a:off x="5485942" y="1280160"/>
+            <a:ext cx="396849" cy="822960"/>
+          </a:xfrm>
+          <a:prstGeom prst="rect">
+            <a:avLst/>
+          </a:prstGeom>
+          <a:solidFill>
+            <a:srgbClr val="F4F5F7"/>
+          </a:solidFill>
+          <a:ln w="15875">
+            <a:solidFill>
+              <a:srgbClr val="C7CBD3"/>
+            </a:solidFill>
+          </a:ln>
+          <a:effectLst/>
+        </p:spPr>
+        <p:style>
+          <a:lnRef idx="1">
+            <a:schemeClr val="accent1"/>
+          </a:lnRef>
+          <a:fillRef idx="3">
+            <a:schemeClr val="accent1"/>
+          </a:fillRef>
+          <a:effectRef idx="2">
+            <a:schemeClr val="accent1"/>
+          </a:effectRef>
+          <a:fontRef idx="minor">
+            <a:schemeClr val="lt1"/>
+          </a:fontRef>
+        </p:style>
+        <p:txBody>
+          <a:bodyPr rtlCol="0" anchor="ctr" wrap="square"/>
+          <a:lstStyle/>
+          <a:p>
+            <a:pPr algn="ctr"/>
+            <a:r>
+              <a:rPr sz="1900" b="0" i="1">
+                <a:solidFill>
+                  <a:srgbClr val="222222"/>
+                </a:solidFill>
+                <a:latin typeface="Cambria Math"/>
+              </a:rPr>
+              <a:t>z</a:t>
+            </a:r>
+          </a:p>
+        </p:txBody>
+      </p:sp>
+      <p:sp>
+        <p:nvSpPr>
+          <p:cNvPr id="10" name="TextBox 9"/>
+          <p:cNvSpPr txBox="1"/>
+          <p:nvPr/>
+        </p:nvSpPr>
+        <p:spPr>
+          <a:xfrm>
+            <a:off x="5165902" y="2130552"/>
+            <a:ext cx="1036929" cy="274320"/>
+          </a:xfrm>
+          <a:prstGeom prst="rect">
+            <a:avLst/>
+          </a:prstGeom>
+          <a:noFill/>
+        </p:spPr>
+        <p:txBody>
+          <a:bodyPr wrap="none" anchor="t" lIns="0" rIns="0" tIns="0" bIns="0">
+            <a:spAutoFit/>
+          </a:bodyPr>
+          <a:lstStyle/>
+          <a:p>
+            <a:pPr algn="ctr">
+              <a:lnSpc>
+                <a:spcPct val="115000"/>
+              </a:lnSpc>
+            </a:pPr>
+            <a:r>
+              <a:rPr sz="1200" b="0" i="1">
+                <a:solidFill>
+                  <a:srgbClr val="5A5A5A"/>
+                </a:solidFill>
+                <a:latin typeface="맑은 고딕"/>
+              </a:rPr>
+              <a:t>m × 1</a:t>
+            </a:r>
+          </a:p>
+        </p:txBody>
+      </p:sp>
+      <p:sp>
+        <p:nvSpPr>
+          <p:cNvPr id="11" name="TextBox 10"/>
+          <p:cNvSpPr txBox="1"/>
+          <p:nvPr/>
+        </p:nvSpPr>
+        <p:spPr>
+          <a:xfrm>
+            <a:off x="6083960" y="1280160"/>
+            <a:ext cx="457200" cy="822960"/>
+          </a:xfrm>
+          <a:prstGeom prst="rect">
+            <a:avLst/>
+          </a:prstGeom>
+          <a:noFill/>
+        </p:spPr>
+        <p:txBody>
+          <a:bodyPr wrap="square" anchor="ctr" lIns="0" rIns="0" tIns="0" bIns="0">
+            <a:spAutoFit/>
+          </a:bodyPr>
+          <a:lstStyle/>
+          <a:p>
+            <a:pPr algn="ctr">
+              <a:lnSpc>
+                <a:spcPct val="115000"/>
+              </a:lnSpc>
+            </a:pPr>
+            <a:r>
+              <a:rPr sz="2500" b="0" i="0">
+                <a:solidFill>
+                  <a:srgbClr val="222222"/>
+                </a:solidFill>
+                <a:latin typeface="맑은 고딕"/>
+              </a:rPr>
+              <a:t>=</a:t>
+            </a:r>
+          </a:p>
+        </p:txBody>
+      </p:sp>
+      <p:sp>
+        <p:nvSpPr>
+          <p:cNvPr id="12" name="Rectangle 11"/>
+          <p:cNvSpPr/>
+          <p:nvPr/>
+        </p:nvSpPr>
+        <p:spPr>
+          <a:xfrm>
+            <a:off x="6788048" y="1280160"/>
+            <a:ext cx="396849" cy="822960"/>
+          </a:xfrm>
+          <a:prstGeom prst="rect">
+            <a:avLst/>
+          </a:prstGeom>
+          <a:solidFill>
+            <a:srgbClr val="F4F5F7"/>
+          </a:solidFill>
+          <a:ln w="15875">
+            <a:solidFill>
+              <a:srgbClr val="C7CBD3"/>
+            </a:solidFill>
+          </a:ln>
+          <a:effectLst/>
+        </p:spPr>
+        <p:style>
+          <a:lnRef idx="1">
+            <a:schemeClr val="accent1"/>
+          </a:lnRef>
+          <a:fillRef idx="3">
+            <a:schemeClr val="accent1"/>
+          </a:fillRef>
+          <a:effectRef idx="2">
+            <a:schemeClr val="accent1"/>
+          </a:effectRef>
+          <a:fontRef idx="minor">
+            <a:schemeClr val="lt1"/>
+          </a:fontRef>
+        </p:style>
+        <p:txBody>
+          <a:bodyPr rtlCol="0" anchor="ctr" wrap="square"/>
+          <a:lstStyle/>
+          <a:p>
+            <a:pPr algn="ctr"/>
+            <a:r>
+              <a:rPr sz="1900" b="0" i="1">
+                <a:solidFill>
+                  <a:srgbClr val="222222"/>
+                </a:solidFill>
+                <a:latin typeface="Cambria Math"/>
+              </a:rPr>
+              <a:t>0</a:t>
+            </a:r>
+          </a:p>
+        </p:txBody>
+      </p:sp>
+      <p:sp>
+        <p:nvSpPr>
+          <p:cNvPr id="13" name="TextBox 12"/>
+          <p:cNvSpPr txBox="1"/>
+          <p:nvPr/>
+        </p:nvSpPr>
+        <p:spPr>
+          <a:xfrm>
+            <a:off x="6468008" y="2130552"/>
+            <a:ext cx="1036929" cy="274320"/>
+          </a:xfrm>
+          <a:prstGeom prst="rect">
+            <a:avLst/>
+          </a:prstGeom>
+          <a:noFill/>
+        </p:spPr>
+        <p:txBody>
+          <a:bodyPr wrap="none" anchor="t" lIns="0" rIns="0" tIns="0" bIns="0">
+            <a:spAutoFit/>
+          </a:bodyPr>
+          <a:lstStyle/>
+          <a:p>
+            <a:pPr algn="ctr">
+              <a:lnSpc>
+                <a:spcPct val="115000"/>
+              </a:lnSpc>
+            </a:pPr>
+            <a:r>
+              <a:rPr sz="1200" b="0" i="1">
+                <a:solidFill>
+                  <a:srgbClr val="5A5A5A"/>
+                </a:solidFill>
+                <a:latin typeface="맑은 고딕"/>
+              </a:rPr>
+              <a:t>n × 1</a:t>
+            </a:r>
+          </a:p>
+        </p:txBody>
+      </p:sp>
+      <p:sp>
+        <p:nvSpPr>
+          <p:cNvPr id="14" name="TextBox 13"/>
+          <p:cNvSpPr txBox="1"/>
+          <p:nvPr/>
+        </p:nvSpPr>
+        <p:spPr>
+          <a:xfrm>
+            <a:off x="7386065" y="1280160"/>
+            <a:ext cx="1188720" cy="822960"/>
+          </a:xfrm>
+          <a:prstGeom prst="rect">
+            <a:avLst/>
+          </a:prstGeom>
+          <a:noFill/>
+        </p:spPr>
+        <p:txBody>
+          <a:bodyPr wrap="square" anchor="ctr" lIns="0" rIns="0" tIns="0" bIns="0">
+            <a:spAutoFit/>
+          </a:bodyPr>
+          <a:lstStyle/>
+          <a:p>
+            <a:pPr algn="ctr">
+              <a:lnSpc>
+                <a:spcPct val="115000"/>
+              </a:lnSpc>
+            </a:pPr>
+            <a:r>
+              <a:rPr sz="1300" b="0" i="0">
+                <a:solidFill>
+                  <a:srgbClr val="5A5A5A"/>
+                </a:solidFill>
+                <a:latin typeface="맑은 고딕"/>
+              </a:rPr>
+              <a:t>(mod q)</a:t>
+            </a:r>
+          </a:p>
+        </p:txBody>
+      </p:sp>
+      <p:sp>
+        <p:nvSpPr>
+          <p:cNvPr id="15" name="TextBox 14"/>
+          <p:cNvSpPr txBox="1"/>
+          <p:nvPr/>
+        </p:nvSpPr>
+        <p:spPr>
+          <a:xfrm>
+            <a:off x="685800" y="2743200"/>
+            <a:ext cx="10789920" cy="3840480"/>
           </a:xfrm>
           <a:prstGeom prst="rect">
             <a:avLst/>
@@ -15962,17 +17604,17 @@
                 <a:spcPct val="125000"/>
               </a:lnSpc>
               <a:spcAft>
-                <a:spcPts val="1400"/>
+                <a:spcPts val="900"/>
               </a:spcAft>
             </a:pPr>
             <a:r>
-              <a:rPr sz="1900">
+              <a:rPr sz="1650">
                 <a:solidFill>
                   <a:srgbClr val="222222"/>
                 </a:solidFill>
                 <a:latin typeface="맑은 고딕"/>
               </a:rPr>
-              <a:t>—  후보 z₁, z₂ ∈ [-B/2, B/2]ᵐ — 총 (B+1)ᵐ 가지</a:t>
+              <a:t>—  n ≥ m 이면: A가 (압도적 확률로) full column rank → Az≡0의 유일해가 z=0뿐이라 SIS 해가 존재하지 않음 — 이후 n &lt; m 을 가정</a:t>
             </a:r>
           </a:p>
           <a:p>
@@ -15981,16 +17623,35 @@
                 <a:spcPct val="125000"/>
               </a:lnSpc>
               <a:spcAft>
-                <a:spcPts val="1400"/>
+                <a:spcPts val="900"/>
               </a:spcAft>
             </a:pPr>
             <a:r>
-              <a:rPr sz="1900">
+              <a:rPr sz="1650">
                 <a:solidFill>
                   <a:srgbClr val="222222"/>
                 </a:solidFill>
                 <a:latin typeface="맑은 고딕"/>
               </a:rPr>
+              <a:t>—  n &lt; m 일 때, 후보 z₁, z₂ ∈ [-B/2, B/2]ᵐ (총 (B+1)ᵐ 가지) 를 생각하면</a:t>
+            </a:r>
+          </a:p>
+          <a:p>
+            <a:pPr>
+              <a:lnSpc>
+                <a:spcPct val="125000"/>
+              </a:lnSpc>
+              <a:spcAft>
+                <a:spcPts val="900"/>
+              </a:spcAft>
+            </a:pPr>
+            <a:r>
+              <a:rPr sz="1650">
+                <a:solidFill>
+                  <a:srgbClr val="222222"/>
+                </a:solidFill>
+                <a:latin typeface="맑은 고딕"/>
+              </a:rPr>
               <a:t>—  (B+1)ᵐ &gt; qⁿ 이면: Az mod q의 가능한 출력은 qⁿ가지뿐 → 비둘기집 원리로 서로 다른 z₁ ≠ z₂가 Az₁ ≡ Az₂ (mod q)를 만족</a:t>
             </a:r>
           </a:p>
@@ -16000,11 +17661,11 @@
                 <a:spcPct val="125000"/>
               </a:lnSpc>
               <a:spcAft>
-                <a:spcPts val="1400"/>
+                <a:spcPts val="900"/>
               </a:spcAft>
             </a:pPr>
             <a:r>
-              <a:rPr sz="1900">
+              <a:rPr sz="1650">
                 <a:solidFill>
                   <a:srgbClr val="222222"/>
                 </a:solidFill>
@@ -16019,11 +17680,11 @@
                 <a:spcPct val="125000"/>
               </a:lnSpc>
               <a:spcAft>
-                <a:spcPts val="1400"/>
+                <a:spcPts val="900"/>
               </a:spcAft>
             </a:pPr>
             <a:r>
-              <a:rPr sz="1900">
+              <a:rPr sz="1650">
                 <a:solidFill>
                   <a:srgbClr val="222222"/>
                 </a:solidFill>
@@ -16998,16 +18659,16 @@
         </p:nvSpPr>
         <p:spPr>
           <a:xfrm>
-            <a:off x="3327044" y="2953512"/>
-            <a:ext cx="1247241" cy="274320"/>
-          </a:xfrm>
-          <a:prstGeom prst="rect">
-            <a:avLst/>
-          </a:prstGeom>
-          <a:noFill/>
-        </p:spPr>
-        <p:txBody>
-          <a:bodyPr wrap="square" anchor="t" lIns="0" rIns="0" tIns="0" bIns="0">
+            <a:off x="3007004" y="2953512"/>
+            <a:ext cx="1887321" cy="274320"/>
+          </a:xfrm>
+          <a:prstGeom prst="rect">
+            <a:avLst/>
+          </a:prstGeom>
+          <a:noFill/>
+        </p:spPr>
+        <p:txBody>
+          <a:bodyPr wrap="none" anchor="t" lIns="0" rIns="0" tIns="0" bIns="0">
             <a:spAutoFit/>
           </a:bodyPr>
           <a:lstStyle/>
@@ -17131,16 +18792,16 @@
         </p:nvSpPr>
         <p:spPr>
           <a:xfrm>
-            <a:off x="5479542" y="2953512"/>
-            <a:ext cx="453542" cy="274320"/>
-          </a:xfrm>
-          <a:prstGeom prst="rect">
-            <a:avLst/>
-          </a:prstGeom>
-          <a:noFill/>
-        </p:spPr>
-        <p:txBody>
-          <a:bodyPr wrap="square" anchor="t" lIns="0" rIns="0" tIns="0" bIns="0">
+            <a:off x="5159502" y="2953512"/>
+            <a:ext cx="1093622" cy="274320"/>
+          </a:xfrm>
+          <a:prstGeom prst="rect">
+            <a:avLst/>
+          </a:prstGeom>
+          <a:noFill/>
+        </p:spPr>
+        <p:txBody>
+          <a:bodyPr wrap="none" anchor="t" lIns="0" rIns="0" tIns="0" bIns="0">
             <a:spAutoFit/>
           </a:bodyPr>
           <a:lstStyle/>
@@ -17264,16 +18925,16 @@
         </p:nvSpPr>
         <p:spPr>
           <a:xfrm>
-            <a:off x="6838340" y="2953512"/>
-            <a:ext cx="453542" cy="274320"/>
-          </a:xfrm>
-          <a:prstGeom prst="rect">
-            <a:avLst/>
-          </a:prstGeom>
-          <a:noFill/>
-        </p:spPr>
-        <p:txBody>
-          <a:bodyPr wrap="square" anchor="t" lIns="0" rIns="0" tIns="0" bIns="0">
+            <a:off x="6518300" y="2953512"/>
+            <a:ext cx="1093622" cy="274320"/>
+          </a:xfrm>
+          <a:prstGeom prst="rect">
+            <a:avLst/>
+          </a:prstGeom>
+          <a:noFill/>
+        </p:spPr>
+        <p:txBody>
+          <a:bodyPr wrap="none" anchor="t" lIns="0" rIns="0" tIns="0" bIns="0">
             <a:spAutoFit/>
           </a:bodyPr>
           <a:lstStyle/>

</xml_diff>